<commit_message>
Auto-generate docs and exports [Quarto]
</commit_message>
<xml_diff>
--- a/exports/quarto/pptx/00_ControlPlaneArchitecture.pptx
+++ b/exports/quarto/pptx/00_ControlPlaneArchitecture.pptx
@@ -3187,7 +3187,7 @@
             </a:pPr>
             <a:r>
               <a:rPr/>
-              <a:t>March 31, 2026</a:t>
+              <a:t>April 2, 2026</a:t>
             </a:r>
           </a:p>
         </p:txBody>
@@ -5666,7 +5666,54 @@
             </a:pPr>
             <a:r>
               <a:rPr/>
-              <a:t>The six control planes operate according to the Seven Core Concepts of UIAO:</a:t>
+              <a:t>The eight core principles governing UIAO are defined in a single source-of-truth document:</a:t>
+            </a:r>
+          </a:p>
+          <a:p>
+            <a:pPr lvl="0" indent="0" marL="1270000">
+              <a:buNone/>
+            </a:pPr>
+            <a:r>
+              <a:rPr sz="2000" b="1"/>
+              <a:t>Canonical reference:</a:t>
+            </a:r>
+            <a:r>
+              <a:rPr sz="2000"/>
+              <a:t> </a:t>
+            </a:r>
+            <a:r>
+              <a:rPr sz="2000">
+                <a:hlinkClick r:id="rId2"/>
+              </a:rPr>
+              <a:t>00_CorePrinciples.md</a:t>
+            </a:r>
+          </a:p>
+          <a:p>
+            <a:pPr lvl="0" indent="0" marL="0">
+              <a:buNone/>
+            </a:pPr>
+            <a:r>
+              <a:rPr/>
+              <a:t>All UIAO documents MUST reference that file rather than duplicating principle text. Any expansion, amendment, or reordering of the principles MUST occur in </a:t>
+            </a:r>
+            <a:r>
+              <a:rPr>
+                <a:latin typeface="Courier"/>
+              </a:rPr>
+              <a:t>00_CorePrinciples.md</a:t>
+            </a:r>
+            <a:r>
+              <a:rPr/>
+              <a:t> first; downstream documents inherit by pointer.</a:t>
+            </a:r>
+          </a:p>
+          <a:p>
+            <a:pPr lvl="0" indent="0" marL="0">
+              <a:buNone/>
+            </a:pPr>
+            <a:r>
+              <a:rPr/>
+              <a:t>For quick orientation the eight principles are:</a:t>
             </a:r>
           </a:p>
           <a:p>
@@ -5675,7 +5722,7 @@
             </a:pPr>
             <a:r>
               <a:rPr/>
-              <a:t>Conversation as the atomic unit</a:t>
+              <a:t>Single Source of Truth (SSOT)</a:t>
             </a:r>
           </a:p>
           <a:p>
@@ -5684,7 +5731,7 @@
             </a:pPr>
             <a:r>
               <a:rPr/>
-              <a:t>Identity as the root namespace</a:t>
+              <a:t>Conversation as the Atomic Unit</a:t>
             </a:r>
           </a:p>
           <a:p>
@@ -5693,7 +5740,7 @@
             </a:pPr>
             <a:r>
               <a:rPr/>
-              <a:t>Deterministic addressing</a:t>
+              <a:t>Identity as the Root Namespace</a:t>
             </a:r>
           </a:p>
           <a:p>
@@ -5702,7 +5749,7 @@
             </a:pPr>
             <a:r>
               <a:rPr/>
-              <a:t>Certificate-anchored overlay</a:t>
+              <a:t>Deterministic Addressing</a:t>
             </a:r>
           </a:p>
           <a:p>
@@ -5711,7 +5758,7 @@
             </a:pPr>
             <a:r>
               <a:rPr/>
-              <a:t>Telemetry as control</a:t>
+              <a:t>Certificate-Anchored Overlay</a:t>
             </a:r>
           </a:p>
           <a:p>
@@ -5720,7 +5767,7 @@
             </a:pPr>
             <a:r>
               <a:rPr/>
-              <a:t>Embedded governance &amp; automation</a:t>
+              <a:t>Telemetry as Control</a:t>
             </a:r>
           </a:p>
           <a:p>
@@ -5729,7 +5776,16 @@
             </a:pPr>
             <a:r>
               <a:rPr/>
-              <a:t>Public service first</a:t>
+              <a:t>Embedded Governance &amp; Automation</a:t>
+            </a:r>
+          </a:p>
+          <a:p>
+            <a:pPr lvl="0" indent="-342900" marL="342900">
+              <a:buAutoNum type="arabicPeriod"/>
+            </a:pPr>
+            <a:r>
+              <a:rPr/>
+              <a:t>Public Service First</a:t>
             </a:r>
           </a:p>
           <a:p>
@@ -5738,7 +5794,17 @@
             </a:pPr>
             <a:r>
               <a:rPr/>
-              <a:t>These concepts are frozen and must appear identically across all UIAO documents.</a:t>
+              <a:t>See </a:t>
+            </a:r>
+            <a:r>
+              <a:rPr>
+                <a:latin typeface="Courier"/>
+              </a:rPr>
+              <a:t>00_CorePrinciples.md</a:t>
+            </a:r>
+            <a:r>
+              <a:rPr/>
+              <a:t> for full definitions, rationale, and compliance anchors.</a:t>
             </a:r>
           </a:p>
         </p:txBody>

</xml_diff>